<commit_message>
docs(readme): Update module completion status and restructure directory overview
</commit_message>
<xml_diff>
--- a/resources/lakehouse.pptx
+++ b/resources/lakehouse.pptx
@@ -3183,7 +3183,7 @@
           <a:p>
             <a:fld id="{DBE79B46-EA7A-443F-98A1-1CFE175F3DC6}" type="datetimeFigureOut">
               <a:rPr lang="es-CO" smtClean="0"/>
-              <a:t>13/04/26</a:t>
+              <a:t>15/04/26</a:t>
             </a:fld>
             <a:endParaRPr lang="es-CO"/>
           </a:p>
@@ -3600,7 +3600,7 @@
           <a:p>
             <a:fld id="{DE3743A8-55EC-4707-B34E-F025D197E566}" type="datetime1">
               <a:rPr lang="es-CO" smtClean="0"/>
-              <a:t>13/04/26</a:t>
+              <a:t>15/04/26</a:t>
             </a:fld>
             <a:endParaRPr lang="es-CO"/>
           </a:p>
@@ -3808,7 +3808,7 @@
           <a:p>
             <a:fld id="{8E885DD1-B6E8-4558-9D0C-CA877C011AB9}" type="datetime1">
               <a:rPr lang="es-CO" smtClean="0"/>
-              <a:t>13/04/26</a:t>
+              <a:t>15/04/26</a:t>
             </a:fld>
             <a:endParaRPr lang="es-CO"/>
           </a:p>
@@ -4026,7 +4026,7 @@
           <a:p>
             <a:fld id="{11C6641F-8875-4A3B-9605-BBA33BA09F7D}" type="datetime1">
               <a:rPr lang="es-CO" smtClean="0"/>
-              <a:t>13/04/26</a:t>
+              <a:t>15/04/26</a:t>
             </a:fld>
             <a:endParaRPr lang="es-CO"/>
           </a:p>
@@ -4912,7 +4912,7 @@
           <a:p>
             <a:fld id="{2D5ED08C-21A1-4459-925F-4AB7494AD6AF}" type="datetime1">
               <a:rPr lang="es-CO" smtClean="0"/>
-              <a:t>13/04/26</a:t>
+              <a:t>15/04/26</a:t>
             </a:fld>
             <a:endParaRPr lang="es-CO"/>
           </a:p>
@@ -5196,7 +5196,7 @@
           <a:p>
             <a:fld id="{773ECA2E-499F-4AAE-8024-2701227D37EA}" type="datetime1">
               <a:rPr lang="es-CO" smtClean="0"/>
-              <a:t>13/04/26</a:t>
+              <a:t>15/04/26</a:t>
             </a:fld>
             <a:endParaRPr lang="es-CO"/>
           </a:p>
@@ -5472,7 +5472,7 @@
           <a:p>
             <a:fld id="{2CF4FA2D-FBA9-4CC5-948E-C6C46AF1CFAC}" type="datetime1">
               <a:rPr lang="es-CO" smtClean="0"/>
-              <a:t>13/04/26</a:t>
+              <a:t>15/04/26</a:t>
             </a:fld>
             <a:endParaRPr lang="es-CO"/>
           </a:p>
@@ -5895,7 +5895,7 @@
           <a:p>
             <a:fld id="{E62688F6-FEFB-4CC4-9AE8-E3FBD5930348}" type="datetime1">
               <a:rPr lang="es-CO" smtClean="0"/>
-              <a:t>13/04/26</a:t>
+              <a:t>15/04/26</a:t>
             </a:fld>
             <a:endParaRPr lang="es-CO"/>
           </a:p>
@@ -6045,7 +6045,7 @@
           <a:p>
             <a:fld id="{F609322D-2C78-47AE-9411-DF09F1B23C5C}" type="datetime1">
               <a:rPr lang="es-CO" smtClean="0"/>
-              <a:t>13/04/26</a:t>
+              <a:t>15/04/26</a:t>
             </a:fld>
             <a:endParaRPr lang="es-CO"/>
           </a:p>
@@ -6166,7 +6166,7 @@
           <a:p>
             <a:fld id="{A67E9942-7877-4E74-8023-51D1A369E009}" type="datetime1">
               <a:rPr lang="es-CO" smtClean="0"/>
-              <a:t>13/04/26</a:t>
+              <a:t>15/04/26</a:t>
             </a:fld>
             <a:endParaRPr lang="es-CO"/>
           </a:p>
@@ -6487,7 +6487,7 @@
           <a:p>
             <a:fld id="{7D430CEB-109D-460C-A8FE-D6830FB86A52}" type="datetime1">
               <a:rPr lang="es-CO" smtClean="0"/>
-              <a:t>13/04/26</a:t>
+              <a:t>15/04/26</a:t>
             </a:fld>
             <a:endParaRPr lang="es-CO"/>
           </a:p>
@@ -6784,7 +6784,7 @@
           <a:p>
             <a:fld id="{5561C093-89F7-4354-A399-E69586B3AAAE}" type="datetime1">
               <a:rPr lang="es-CO" smtClean="0"/>
-              <a:t>13/04/26</a:t>
+              <a:t>15/04/26</a:t>
             </a:fld>
             <a:endParaRPr lang="es-CO"/>
           </a:p>
@@ -7035,7 +7035,7 @@
           <a:p>
             <a:fld id="{11AE3624-E68E-4A2B-A326-65DBF28F05D7}" type="datetime1">
               <a:rPr lang="es-CO" smtClean="0"/>
-              <a:t>13/04/26</a:t>
+              <a:t>15/04/26</a:t>
             </a:fld>
             <a:endParaRPr lang="es-CO"/>
           </a:p>
@@ -14532,23 +14532,104 @@
               <a:defRPr sz="1600"/>
             </a:pPr>
             <a:r>
-              <a:t>Bronze | Calidad: cruda | Esquema: flexible | Usuarios: ingenieros</a:t>
-            </a:r>
+              <a:rPr dirty="0"/>
+              <a:t>Bronze | Calidad: </a:t>
+            </a:r>
+            <a:r>
+              <a:rPr dirty="0" err="1"/>
+              <a:t>cruda</a:t>
+            </a:r>
+            <a:r>
+              <a:rPr dirty="0"/>
+              <a:t> | </a:t>
+            </a:r>
+            <a:r>
+              <a:rPr dirty="0" err="1"/>
+              <a:t>Esquema</a:t>
+            </a:r>
+            <a:r>
+              <a:rPr dirty="0"/>
+              <a:t>: flexible | </a:t>
+            </a:r>
+            <a:r>
+              <a:rPr dirty="0" err="1"/>
+              <a:t>Usuarios</a:t>
+            </a:r>
+            <a:r>
+              <a:rPr dirty="0"/>
+              <a:t>: </a:t>
+            </a:r>
+            <a:r>
+              <a:rPr dirty="0" err="1"/>
+              <a:t>ingenieros</a:t>
+            </a:r>
+            <a:endParaRPr dirty="0"/>
           </a:p>
           <a:p>
             <a:pPr lvl="1">
               <a:defRPr sz="1400"/>
             </a:pPr>
             <a:r>
-              <a:t>Actualización: append | Formato: Parquet/JSON | Ej: logs_raw</a:t>
-            </a:r>
+              <a:rPr dirty="0" err="1"/>
+              <a:t>Actualización</a:t>
+            </a:r>
+            <a:r>
+              <a:rPr dirty="0"/>
+              <a:t>: append | Formato: Parquet/JSON | </a:t>
+            </a:r>
+            <a:r>
+              <a:rPr dirty="0" err="1"/>
+              <a:t>Ej</a:t>
+            </a:r>
+            <a:r>
+              <a:rPr dirty="0"/>
+              <a:t>: </a:t>
+            </a:r>
+            <a:r>
+              <a:rPr dirty="0" err="1"/>
+              <a:t>logs_raw</a:t>
+            </a:r>
+            <a:endParaRPr dirty="0"/>
           </a:p>
           <a:p>
             <a:pPr>
               <a:defRPr sz="1600"/>
             </a:pPr>
             <a:r>
-              <a:t>Silver | Calidad: limpia | Esquema: enforced | Usuarios: analistas/DS</a:t>
+              <a:rPr dirty="0"/>
+              <a:t>Silver | Calidad: </a:t>
+            </a:r>
+            <a:r>
+              <a:rPr dirty="0" err="1"/>
+              <a:t>limpia</a:t>
+            </a:r>
+            <a:r>
+              <a:rPr dirty="0"/>
+              <a:t> | </a:t>
+            </a:r>
+            <a:r>
+              <a:rPr dirty="0" err="1"/>
+              <a:t>Esquema</a:t>
+            </a:r>
+            <a:r>
+              <a:rPr dirty="0"/>
+              <a:t>: enforced | </a:t>
+            </a:r>
+            <a:r>
+              <a:rPr dirty="0" err="1"/>
+              <a:t>Usuarios</a:t>
+            </a:r>
+            <a:r>
+              <a:rPr dirty="0"/>
+              <a:t>: </a:t>
+            </a:r>
+            <a:r>
+              <a:rPr dirty="0" err="1"/>
+              <a:t>analistas</a:t>
+            </a:r>
+            <a:r>
+              <a:rPr dirty="0"/>
+              <a:t>/DS</a:t>
             </a:r>
           </a:p>
           <a:p>
@@ -14556,24 +14637,98 @@
               <a:defRPr sz="1400"/>
             </a:pPr>
             <a:r>
-              <a:t>Actualización: merge/upsert | Formato: Delta/Iceberg | Ej: users_cleaned</a:t>
-            </a:r>
+              <a:rPr dirty="0" err="1"/>
+              <a:t>Actualización</a:t>
+            </a:r>
+            <a:r>
+              <a:rPr dirty="0"/>
+              <a:t>: merge/</a:t>
+            </a:r>
+            <a:r>
+              <a:rPr dirty="0" err="1"/>
+              <a:t>upsert</a:t>
+            </a:r>
+            <a:r>
+              <a:rPr dirty="0"/>
+              <a:t> | Formato: Delta/Iceberg | </a:t>
+            </a:r>
+            <a:r>
+              <a:rPr dirty="0" err="1"/>
+              <a:t>Ej</a:t>
+            </a:r>
+            <a:r>
+              <a:rPr dirty="0"/>
+              <a:t>: </a:t>
+            </a:r>
+            <a:r>
+              <a:rPr dirty="0" err="1"/>
+              <a:t>users_cleaned</a:t>
+            </a:r>
+            <a:endParaRPr dirty="0"/>
           </a:p>
           <a:p>
             <a:pPr>
               <a:defRPr sz="1600"/>
             </a:pPr>
             <a:r>
-              <a:t>Gold | Calidad: agregada | Esquema: star schema | Usuarios: BI/ejecutivos</a:t>
-            </a:r>
+              <a:rPr dirty="0"/>
+              <a:t>Gold | Calidad: </a:t>
+            </a:r>
+            <a:r>
+              <a:rPr dirty="0" err="1"/>
+              <a:t>agregada</a:t>
+            </a:r>
+            <a:r>
+              <a:rPr dirty="0"/>
+              <a:t> | </a:t>
+            </a:r>
+            <a:r>
+              <a:rPr dirty="0" err="1"/>
+              <a:t>Esquema</a:t>
+            </a:r>
+            <a:r>
+              <a:rPr dirty="0"/>
+              <a:t>: star schema | </a:t>
+            </a:r>
+            <a:r>
+              <a:rPr dirty="0" err="1"/>
+              <a:t>Usuarios</a:t>
+            </a:r>
+            <a:r>
+              <a:rPr dirty="0"/>
+              <a:t>: BI/</a:t>
+            </a:r>
+            <a:r>
+              <a:rPr dirty="0" err="1"/>
+              <a:t>ejecutivos</a:t>
+            </a:r>
+            <a:endParaRPr dirty="0"/>
           </a:p>
           <a:p>
             <a:pPr lvl="1">
               <a:defRPr sz="1400"/>
             </a:pPr>
             <a:r>
-              <a:t>Actualización: scheduled | Formato: Delta/Iceberg | Ej: revenue_monthly</a:t>
-            </a:r>
+              <a:rPr dirty="0" err="1"/>
+              <a:t>Actualización</a:t>
+            </a:r>
+            <a:r>
+              <a:rPr dirty="0"/>
+              <a:t>: scheduled | Formato: Delta/Iceberg | </a:t>
+            </a:r>
+            <a:r>
+              <a:rPr dirty="0" err="1"/>
+              <a:t>Ej</a:t>
+            </a:r>
+            <a:r>
+              <a:rPr dirty="0"/>
+              <a:t>: </a:t>
+            </a:r>
+            <a:r>
+              <a:rPr dirty="0" err="1"/>
+              <a:t>revenue_monthly</a:t>
+            </a:r>
+            <a:endParaRPr dirty="0"/>
           </a:p>
         </p:txBody>
       </p:sp>
@@ -16089,6 +16244,7 @@
               <a:defRPr sz="1600"/>
             </a:pPr>
             <a:r>
+              <a:rPr dirty="0"/>
               <a:t>Organización con Medallion + Unity Catalog:</a:t>
             </a:r>
           </a:p>
@@ -16097,7 +16253,36 @@
               <a:defRPr sz="1400"/>
             </a:pPr>
             <a:r>
-              <a:t>Catálogo: medallion (o nombre del proyecto/dominio)</a:t>
+              <a:rPr dirty="0" err="1"/>
+              <a:t>Catálogo</a:t>
+            </a:r>
+            <a:r>
+              <a:rPr dirty="0"/>
+              <a:t>: medallion (o </a:t>
+            </a:r>
+            <a:r>
+              <a:rPr dirty="0" err="1"/>
+              <a:t>nombre</a:t>
+            </a:r>
+            <a:r>
+              <a:rPr dirty="0"/>
+              <a:t> del </a:t>
+            </a:r>
+            <a:r>
+              <a:rPr dirty="0" err="1"/>
+              <a:t>proyecto</a:t>
+            </a:r>
+            <a:r>
+              <a:rPr dirty="0"/>
+              <a:t>/</a:t>
+            </a:r>
+            <a:r>
+              <a:rPr dirty="0" err="1"/>
+              <a:t>dominio</a:t>
+            </a:r>
+            <a:r>
+              <a:rPr dirty="0"/>
+              <a:t>)</a:t>
             </a:r>
           </a:p>
           <a:p>
@@ -16105,7 +16290,12 @@
               <a:defRPr sz="1400"/>
             </a:pPr>
             <a:r>
-              <a:t>Esquemas: bronze, silver, gold</a:t>
+              <a:rPr dirty="0" err="1"/>
+              <a:t>Esquemas</a:t>
+            </a:r>
+            <a:r>
+              <a:rPr dirty="0"/>
+              <a:t>: bronze, silver, gold</a:t>
             </a:r>
           </a:p>
           <a:p>
@@ -16113,7 +16303,72 @@
               <a:defRPr sz="1400"/>
             </a:pPr>
             <a:r>
-              <a:t>Tablas: medallion.bronze.travel_times_raw</a:t>
+              <a:rPr dirty="0" err="1"/>
+              <a:t>Tablas</a:t>
+            </a:r>
+            <a:r>
+              <a:rPr dirty="0"/>
+              <a:t>: </a:t>
+            </a:r>
+            <a:endParaRPr lang="es-419" dirty="0"/>
+          </a:p>
+          <a:p>
+            <a:pPr lvl="2">
+              <a:defRPr sz="1400"/>
+            </a:pPr>
+            <a:r>
+              <a:rPr dirty="0" err="1"/>
+              <a:t>medallion.bronze.travel_times_raw</a:t>
+            </a:r>
+            <a:endParaRPr dirty="0"/>
+          </a:p>
+          <a:p>
+            <a:pPr lvl="2">
+              <a:defRPr sz="1400"/>
+            </a:pPr>
+            <a:r>
+              <a:rPr dirty="0" err="1"/>
+              <a:t>medallion.silver.travel_times_clean</a:t>
+            </a:r>
+            <a:endParaRPr dirty="0"/>
+          </a:p>
+          <a:p>
+            <a:pPr lvl="2">
+              <a:defRPr sz="1400"/>
+            </a:pPr>
+            <a:r>
+              <a:rPr dirty="0" err="1"/>
+              <a:t>medallion.gold.city_metrics</a:t>
+            </a:r>
+            <a:endParaRPr dirty="0"/>
+          </a:p>
+          <a:p>
+            <a:pPr>
+              <a:defRPr sz="1600"/>
+            </a:pPr>
+            <a:r>
+              <a:rPr dirty="0" err="1"/>
+              <a:t>Volúmenes</a:t>
+            </a:r>
+            <a:r>
+              <a:rPr dirty="0"/>
+              <a:t> para </a:t>
+            </a:r>
+            <a:r>
+              <a:rPr dirty="0" err="1"/>
+              <a:t>archivos</a:t>
+            </a:r>
+            <a:r>
+              <a:rPr dirty="0"/>
+              <a:t> no </a:t>
+            </a:r>
+            <a:r>
+              <a:rPr dirty="0" err="1"/>
+              <a:t>tabulares</a:t>
+            </a:r>
+            <a:r>
+              <a:rPr dirty="0"/>
+              <a:t>:</a:t>
             </a:r>
           </a:p>
           <a:p>
@@ -16121,15 +16376,46 @@
               <a:defRPr sz="1400"/>
             </a:pPr>
             <a:r>
-              <a:t>medallion.silver.travel_times_clean</a:t>
-            </a:r>
+              <a:rPr dirty="0"/>
+              <a:t>CREATE VOLUME </a:t>
+            </a:r>
+            <a:r>
+              <a:rPr dirty="0" err="1"/>
+              <a:t>medallion.bronze.landing_files</a:t>
+            </a:r>
+            <a:endParaRPr dirty="0"/>
           </a:p>
           <a:p>
             <a:pPr lvl="1">
               <a:defRPr sz="1400"/>
             </a:pPr>
             <a:r>
-              <a:t>medallion.gold.city_metrics</a:t>
+              <a:rPr dirty="0"/>
+              <a:t>Subir CSVs, PDFs, </a:t>
+            </a:r>
+            <a:r>
+              <a:rPr dirty="0" err="1"/>
+              <a:t>imágenes</a:t>
+            </a:r>
+            <a:r>
+              <a:rPr dirty="0"/>
+              <a:t> al </a:t>
+            </a:r>
+            <a:r>
+              <a:rPr dirty="0" err="1"/>
+              <a:t>volumen</a:t>
+            </a:r>
+            <a:r>
+              <a:rPr dirty="0"/>
+              <a:t> (</a:t>
+            </a:r>
+            <a:r>
+              <a:rPr dirty="0" err="1"/>
+              <a:t>reemplaza</a:t>
+            </a:r>
+            <a:r>
+              <a:rPr dirty="0"/>
+              <a:t> DBFS)</a:t>
             </a:r>
           </a:p>
           <a:p>
@@ -16137,39 +16423,86 @@
               <a:defRPr sz="1600"/>
             </a:pPr>
             <a:r>
-              <a:t>Volúmenes para archivos no tabulares:</a:t>
-            </a:r>
-          </a:p>
-          <a:p>
-            <a:pPr lvl="1">
-              <a:defRPr sz="1400"/>
-            </a:pPr>
-            <a:r>
-              <a:t>CREATE VOLUME medallion.bronze.landing_files</a:t>
-            </a:r>
-          </a:p>
-          <a:p>
-            <a:pPr lvl="1">
-              <a:defRPr sz="1400"/>
-            </a:pPr>
-            <a:r>
-              <a:t>Subir CSVs, PDFs, imágenes al volumen (reemplaza DBFS)</a:t>
-            </a:r>
+              <a:rPr dirty="0"/>
+              <a:t>Cada </a:t>
+            </a:r>
+            <a:r>
+              <a:rPr dirty="0" err="1"/>
+              <a:t>capa</a:t>
+            </a:r>
+            <a:r>
+              <a:rPr dirty="0"/>
+              <a:t> con </a:t>
+            </a:r>
+            <a:r>
+              <a:rPr dirty="0" err="1"/>
+              <a:t>permisos</a:t>
+            </a:r>
+            <a:r>
+              <a:rPr dirty="0"/>
+              <a:t> </a:t>
+            </a:r>
+            <a:r>
+              <a:rPr dirty="0" err="1"/>
+              <a:t>diferenciados</a:t>
+            </a:r>
+            <a:r>
+              <a:rPr dirty="0"/>
+              <a:t> </a:t>
+            </a:r>
+            <a:r>
+              <a:rPr dirty="0" err="1"/>
+              <a:t>por</a:t>
+            </a:r>
+            <a:r>
+              <a:rPr dirty="0"/>
+              <a:t> </a:t>
+            </a:r>
+            <a:r>
+              <a:rPr dirty="0" err="1"/>
+              <a:t>rol</a:t>
+            </a:r>
+            <a:endParaRPr dirty="0"/>
           </a:p>
           <a:p>
             <a:pPr>
               <a:defRPr sz="1600"/>
             </a:pPr>
             <a:r>
-              <a:t>Cada capa con permisos diferenciados por rol</a:t>
-            </a:r>
-          </a:p>
-          <a:p>
-            <a:pPr>
-              <a:defRPr sz="1600"/>
-            </a:pPr>
-            <a:r>
-              <a:t>Esto es lo que van a ver en su workspace de Databricks</a:t>
+              <a:rPr dirty="0"/>
+              <a:t>Esto es lo </a:t>
+            </a:r>
+            <a:r>
+              <a:rPr dirty="0" err="1"/>
+              <a:t>que</a:t>
+            </a:r>
+            <a:r>
+              <a:rPr dirty="0"/>
+              <a:t> van a </a:t>
+            </a:r>
+            <a:r>
+              <a:rPr dirty="0" err="1"/>
+              <a:t>ver</a:t>
+            </a:r>
+            <a:r>
+              <a:rPr dirty="0"/>
+              <a:t> </a:t>
+            </a:r>
+            <a:r>
+              <a:rPr dirty="0" err="1"/>
+              <a:t>en</a:t>
+            </a:r>
+            <a:r>
+              <a:rPr dirty="0"/>
+              <a:t> </a:t>
+            </a:r>
+            <a:r>
+              <a:rPr dirty="0" err="1"/>
+              <a:t>su</a:t>
+            </a:r>
+            <a:r>
+              <a:rPr dirty="0"/>
+              <a:t> workspace de Databricks</a:t>
             </a:r>
           </a:p>
         </p:txBody>
@@ -16598,8 +16931,18 @@
             </a:r>
             <a:r>
               <a:rPr dirty="0"/>
-              <a:t> — es </a:t>
-            </a:r>
+              <a:t> es </a:t>
+            </a:r>
+            <a:r>
+              <a:rPr lang="es-419"/>
+              <a:t>:</a:t>
+            </a:r>
+            <a:endParaRPr lang="es-419" dirty="0"/>
+          </a:p>
+          <a:p>
+            <a:pPr lvl="1">
+              <a:defRPr sz="1600"/>
+            </a:pPr>
             <a:r>
               <a:rPr dirty="0" err="1"/>
               <a:t>almacenamiento</a:t>
@@ -16616,14 +16959,13 @@
               <a:rPr dirty="0"/>
               <a:t> +</a:t>
             </a:r>
-          </a:p>
-          <a:p>
-            <a:pPr lvl="1">
-              <a:defRPr sz="1400"/>
-            </a:pPr>
+            <a:r>
+              <a:rPr lang="es-419" dirty="0"/>
+              <a:t> f</a:t>
+            </a:r>
             <a:r>
               <a:rPr dirty="0" err="1"/>
-              <a:t>formatos</a:t>
+              <a:t>ormatos</a:t>
             </a:r>
             <a:r>
               <a:rPr dirty="0"/>
@@ -17862,6 +18204,26 @@
 </file>
 
 <file path=customXml/item1.xml><?xml version="1.0" encoding="utf-8"?>
+<p:properties xmlns:p="http://schemas.microsoft.com/office/2006/metadata/properties" xmlns:xsi="http://www.w3.org/2001/XMLSchema-instance" xmlns:pc="http://schemas.microsoft.com/office/infopath/2007/PartnerControls">
+  <documentManagement>
+    <_activity xmlns="645ae1ed-e6b3-44e5-a4c8-a24e7bdc788d" xsi:nil="true"/>
+    <_ip_UnifiedCompliancePolicyUIAction xmlns="http://schemas.microsoft.com/sharepoint/v3" xsi:nil="true"/>
+    <IMAddress xmlns="http://schemas.microsoft.com/sharepoint/v3" xsi:nil="true"/>
+    <_ip_UnifiedCompliancePolicyProperties xmlns="http://schemas.microsoft.com/sharepoint/v3" xsi:nil="true"/>
+  </documentManagement>
+</p:properties>
+</file>
+
+<file path=customXml/item2.xml><?xml version="1.0" encoding="utf-8"?>
+<?mso-contentType ?>
+<FormTemplates xmlns="http://schemas.microsoft.com/sharepoint/v3/contenttype/forms">
+  <Display>DocumentLibraryForm</Display>
+  <Edit>DocumentLibraryForm</Edit>
+  <New>DocumentLibraryForm</New>
+</FormTemplates>
+</file>
+
+<file path=customXml/item3.xml><?xml version="1.0" encoding="utf-8"?>
 <ct:contentTypeSchema xmlns:ct="http://schemas.microsoft.com/office/2006/metadata/contentType" xmlns:ma="http://schemas.microsoft.com/office/2006/metadata/properties/metaAttributes" ct:_="" ma:_="" ma:contentTypeName="Document" ma:contentTypeID="0x010100653DC2FCB227EA42B7B265435BD19DFC" ma:contentTypeVersion="21" ma:contentTypeDescription="Create a new document." ma:contentTypeScope="" ma:versionID="cb32a70cc5ea0fb74e920c17bfb67e81">
   <xsd:schema xmlns:xsd="http://www.w3.org/2001/XMLSchema" xmlns:xs="http://www.w3.org/2001/XMLSchema" xmlns:p="http://schemas.microsoft.com/office/2006/metadata/properties" xmlns:ns1="http://schemas.microsoft.com/sharepoint/v3" xmlns:ns3="0e0238ec-92e3-425a-acca-874cf401e5b6" xmlns:ns4="645ae1ed-e6b3-44e5-a4c8-a24e7bdc788d" targetNamespace="http://schemas.microsoft.com/office/2006/metadata/properties" ma:root="true" ma:fieldsID="54103e6dfc2d7663b215d6e0a564d535" ns1:_="" ns3:_="" ns4:_="">
     <xsd:import namespace="http://schemas.microsoft.com/sharepoint/v3"/>
@@ -18137,27 +18499,33 @@
 </ct:contentTypeSchema>
 </file>
 
-<file path=customXml/item2.xml><?xml version="1.0" encoding="utf-8"?>
-<p:properties xmlns:p="http://schemas.microsoft.com/office/2006/metadata/properties" xmlns:xsi="http://www.w3.org/2001/XMLSchema-instance" xmlns:pc="http://schemas.microsoft.com/office/infopath/2007/PartnerControls">
-  <documentManagement>
-    <_activity xmlns="645ae1ed-e6b3-44e5-a4c8-a24e7bdc788d" xsi:nil="true"/>
-    <_ip_UnifiedCompliancePolicyUIAction xmlns="http://schemas.microsoft.com/sharepoint/v3" xsi:nil="true"/>
-    <IMAddress xmlns="http://schemas.microsoft.com/sharepoint/v3" xsi:nil="true"/>
-    <_ip_UnifiedCompliancePolicyProperties xmlns="http://schemas.microsoft.com/sharepoint/v3" xsi:nil="true"/>
-  </documentManagement>
-</p:properties>
+<file path=customXml/itemProps1.xml><?xml version="1.0" encoding="utf-8"?>
+<ds:datastoreItem xmlns:ds="http://schemas.openxmlformats.org/officeDocument/2006/customXml" ds:itemID="{4C409CEB-91C5-4691-B8BA-9DA32C54959C}">
+  <ds:schemaRefs>
+    <ds:schemaRef ds:uri="http://purl.org/dc/elements/1.1/"/>
+    <ds:schemaRef ds:uri="0e0238ec-92e3-425a-acca-874cf401e5b6"/>
+    <ds:schemaRef ds:uri="645ae1ed-e6b3-44e5-a4c8-a24e7bdc788d"/>
+    <ds:schemaRef ds:uri="http://purl.org/dc/dcmitype/"/>
+    <ds:schemaRef ds:uri="http://schemas.microsoft.com/office/2006/documentManagement/types"/>
+    <ds:schemaRef ds:uri="http://schemas.microsoft.com/office/2006/metadata/properties"/>
+    <ds:schemaRef ds:uri="http://schemas.microsoft.com/sharepoint/v3"/>
+    <ds:schemaRef ds:uri="http://www.w3.org/XML/1998/namespace"/>
+    <ds:schemaRef ds:uri="http://schemas.microsoft.com/office/infopath/2007/PartnerControls"/>
+    <ds:schemaRef ds:uri="http://schemas.openxmlformats.org/package/2006/metadata/core-properties"/>
+    <ds:schemaRef ds:uri="http://purl.org/dc/terms/"/>
+  </ds:schemaRefs>
+</ds:datastoreItem>
 </file>
 
-<file path=customXml/item3.xml><?xml version="1.0" encoding="utf-8"?>
-<?mso-contentType ?>
-<FormTemplates xmlns="http://schemas.microsoft.com/sharepoint/v3/contenttype/forms">
-  <Display>DocumentLibraryForm</Display>
-  <Edit>DocumentLibraryForm</Edit>
-  <New>DocumentLibraryForm</New>
-</FormTemplates>
+<file path=customXml/itemProps2.xml><?xml version="1.0" encoding="utf-8"?>
+<ds:datastoreItem xmlns:ds="http://schemas.openxmlformats.org/officeDocument/2006/customXml" ds:itemID="{8087687E-FD40-4BD4-8C90-A39D8D799A61}">
+  <ds:schemaRefs>
+    <ds:schemaRef ds:uri="http://schemas.microsoft.com/sharepoint/v3/contenttype/forms"/>
+  </ds:schemaRefs>
+</ds:datastoreItem>
 </file>
 
-<file path=customXml/itemProps1.xml><?xml version="1.0" encoding="utf-8"?>
+<file path=customXml/itemProps3.xml><?xml version="1.0" encoding="utf-8"?>
 <ds:datastoreItem xmlns:ds="http://schemas.openxmlformats.org/officeDocument/2006/customXml" ds:itemID="{0CB5CB8F-C866-413E-AEA2-08ACD39D6312}">
   <ds:schemaRefs>
     <ds:schemaRef ds:uri="http://schemas.microsoft.com/office/2006/metadata/contentType"/>
@@ -18175,30 +18543,4 @@
     <ds:schemaRef ds:uri="http://schemas.microsoft.com/internal/obd"/>
   </ds:schemaRefs>
 </ds:datastoreItem>
-</file>
-
-<file path=customXml/itemProps2.xml><?xml version="1.0" encoding="utf-8"?>
-<ds:datastoreItem xmlns:ds="http://schemas.openxmlformats.org/officeDocument/2006/customXml" ds:itemID="{4C409CEB-91C5-4691-B8BA-9DA32C54959C}">
-  <ds:schemaRefs>
-    <ds:schemaRef ds:uri="http://purl.org/dc/elements/1.1/"/>
-    <ds:schemaRef ds:uri="0e0238ec-92e3-425a-acca-874cf401e5b6"/>
-    <ds:schemaRef ds:uri="645ae1ed-e6b3-44e5-a4c8-a24e7bdc788d"/>
-    <ds:schemaRef ds:uri="http://purl.org/dc/dcmitype/"/>
-    <ds:schemaRef ds:uri="http://schemas.microsoft.com/office/2006/documentManagement/types"/>
-    <ds:schemaRef ds:uri="http://schemas.microsoft.com/office/2006/metadata/properties"/>
-    <ds:schemaRef ds:uri="http://schemas.microsoft.com/sharepoint/v3"/>
-    <ds:schemaRef ds:uri="http://www.w3.org/XML/1998/namespace"/>
-    <ds:schemaRef ds:uri="http://schemas.microsoft.com/office/infopath/2007/PartnerControls"/>
-    <ds:schemaRef ds:uri="http://schemas.openxmlformats.org/package/2006/metadata/core-properties"/>
-    <ds:schemaRef ds:uri="http://purl.org/dc/terms/"/>
-  </ds:schemaRefs>
-</ds:datastoreItem>
-</file>
-
-<file path=customXml/itemProps3.xml><?xml version="1.0" encoding="utf-8"?>
-<ds:datastoreItem xmlns:ds="http://schemas.openxmlformats.org/officeDocument/2006/customXml" ds:itemID="{8087687E-FD40-4BD4-8C90-A39D8D799A61}">
-  <ds:schemaRefs>
-    <ds:schemaRef ds:uri="http://schemas.microsoft.com/sharepoint/v3/contenttype/forms"/>
-  </ds:schemaRefs>
-</ds:datastoreItem>
 </file>
</xml_diff>